<commit_message>
docs: entregables — accesos rápidos en README + deck alineado con el PDF
README (how-to para docentes):
- Bloque 'Accesos rápidos' al inicio: repo público, rama, URLs de la app,
  y links a todos los entregables (documento final, deck, HOWTO, FAQ,
  reglas, tests, evidencias). Cubre el material de accesos/URLs.
- Tabla de verificación ampliada a 7 casos (suma índice /actuator y
  /proxy sin sesión, las 2 brechas cerradas).

Presentación (docs/presentacion-tpe-waf.pptx):
- slide 8 (RESULTADOS): 23/23 → 27/27 (2 lugares) + audit log refleja
  99002-5 e índice actuator.
- slide 5 (REGLAS): 99001 menciona el índice; fila de proxy plega 99004/99005.
Consistente con el documento final PDF en el que nos vamos a apoyar.

Co-Authored-By: Claude Fable 5 <noreply@anthropic.com>
</commit_message>
<xml_diff>
--- a/docs/presentacion-tpe-waf.pptx
+++ b/docs/presentacion-tpe-waf.pptx
@@ -8429,7 +8429,7 @@
                 </a:solidFill>
                 <a:latin typeface="Calibri"/>
               </a:rPr>
-              <a:t>  Actuator sensible (preserva /health)</a:t>
+              <a:t>  Actuator + índice (preserva /health)</a:t>
             </a:r>
           </a:p>
           <a:p>
@@ -8482,7 +8482,7 @@
                 </a:solidFill>
                 <a:latin typeface="Consolas"/>
               </a:rPr>
-              <a:t>99003</a:t>
+              <a:t>99003-5</a:t>
             </a:r>
             <a:r>
               <a:rPr sz="1350" b="0" i="0">
@@ -8491,7 +8491,7 @@
                 </a:solidFill>
                 <a:latin typeface="Calibri"/>
               </a:rPr>
-              <a:t>  rutas admin de backend vía proxy</a:t>
+              <a:t>  rutas admin + /proxy/* sin sesión</a:t>
             </a:r>
           </a:p>
           <a:p>
@@ -11548,7 +11548,7 @@
                 </a:solidFill>
                 <a:latin typeface="Trebuchet MS"/>
               </a:rPr>
-              <a:t>23/23 y la prueba en el audit log</a:t>
+              <a:t>27/27 y la prueba en el audit log</a:t>
             </a:r>
           </a:p>
         </p:txBody>
@@ -11641,7 +11641,7 @@
                 </a:solidFill>
                 <a:latin typeface="Trebuchet MS"/>
               </a:rPr>
-              <a:t>23/23</a:t>
+              <a:t>27/27</a:t>
             </a:r>
           </a:p>
         </p:txBody>
@@ -11877,7 +11877,7 @@
                 </a:solidFill>
                 <a:latin typeface="Calibri"/>
               </a:rPr>
-              <a:t>/actuator/{info,metrics,prometheus,env}</a:t>
+              <a:t>/actuator/{info,metrics,prometheus,env} + índice</a:t>
             </a:r>
           </a:p>
           <a:p>
@@ -11899,7 +11899,7 @@
                 </a:solidFill>
                 <a:latin typeface="Consolas"/>
               </a:rPr>
-              <a:t>Custom 99002   </a:t>
+              <a:t>Custom 99002-5 </a:t>
             </a:r>
             <a:r>
               <a:rPr sz="1250" b="0" i="0">
@@ -11908,7 +11908,7 @@
                 </a:solidFill>
                 <a:latin typeface="Calibri"/>
               </a:rPr>
-              <a:t>traversal .. / %2e%2e en /proxy/*</a:t>
+              <a:t>traversal y /proxy/* sin sesión válida</a:t>
             </a:r>
           </a:p>
           <a:p>

</xml_diff>